<commit_message>
slides: update poster and talk decks (Phase 6/7 results integrated)
Co-Authored-By: Claude Sonnet 4.6 <noreply@anthropic.com>
</commit_message>
<xml_diff>
--- a/talk_cs763.pptx
+++ b/talk_cs763.pptx
@@ -4,6 +4,9 @@
   <p:sldMasterIdLst>
     <p:sldMasterId id="2147483648" r:id="rId1"/>
   </p:sldMasterIdLst>
+  <p:notesMasterIdLst>
+    <p:notesMasterId r:id="rId16"/>
+  </p:notesMasterIdLst>
   <p:sldIdLst>
     <p:sldId id="256" r:id="rId2"/>
     <p:sldId id="257" r:id="rId3"/>
@@ -20,9 +23,6 @@
     <p:sldId id="268" r:id="rId14"/>
     <p:sldId id="269" r:id="rId15"/>
   </p:sldIdLst>
-  <p:notesMasterIdLst>
-    <p:notesMasterId r:id="rId16"/>
-  </p:notesMasterIdLst>
   <p:sldSz cx="12192000" cy="6858000"/>
   <p:notesSz cx="6858000" cy="12192000"/>
   <p:defaultTextStyle>
@@ -117,7 +117,41 @@
       </a:defRPr>
     </a:lvl9pPr>
   </p:defaultTextStyle>
+  <p:extLst>
+    <p:ext uri="{EFAFB233-063F-42B5-8137-9DF3F51BA10A}">
+      <p15:sldGuideLst xmlns:p15="http://schemas.microsoft.com/office/powerpoint/2012/main"/>
+    </p:ext>
+  </p:extLst>
 </p:presentation>
+</file>
+
+<file path=ppt/changesInfos/changesInfo1.xml><?xml version="1.0" encoding="utf-8"?>
+<pc:chgInfo xmlns:a="http://schemas.openxmlformats.org/drawingml/2006/main" xmlns:r="http://schemas.openxmlformats.org/officeDocument/2006/relationships" xmlns:ac="http://schemas.microsoft.com/office/drawing/2013/main/command" xmlns:pc="http://schemas.microsoft.com/office/powerpoint/2013/main/command">
+  <pc:docChgLst>
+    <pc:chgData name="Muhammad Musa" userId="cee12d80-de73-4209-82fb-d15a4712f377" providerId="ADAL" clId="{45D44477-213E-4C82-8096-BF004DBC2219}"/>
+    <pc:docChg chg="modSld">
+      <pc:chgData name="Muhammad Musa" userId="cee12d80-de73-4209-82fb-d15a4712f377" providerId="ADAL" clId="{45D44477-213E-4C82-8096-BF004DBC2219}" dt="2026-05-04T00:19:43.706" v="0" actId="1035"/>
+      <pc:docMkLst>
+        <pc:docMk/>
+      </pc:docMkLst>
+      <pc:sldChg chg="modSp mod">
+        <pc:chgData name="Muhammad Musa" userId="cee12d80-de73-4209-82fb-d15a4712f377" providerId="ADAL" clId="{45D44477-213E-4C82-8096-BF004DBC2219}" dt="2026-05-04T00:19:43.706" v="0" actId="1035"/>
+        <pc:sldMkLst>
+          <pc:docMk/>
+          <pc:sldMk cId="0" sldId="261"/>
+        </pc:sldMkLst>
+        <pc:picChg chg="mod">
+          <ac:chgData name="Muhammad Musa" userId="cee12d80-de73-4209-82fb-d15a4712f377" providerId="ADAL" clId="{45D44477-213E-4C82-8096-BF004DBC2219}" dt="2026-05-04T00:19:43.706" v="0" actId="1035"/>
+          <ac:picMkLst>
+            <pc:docMk/>
+            <pc:sldMk cId="0" sldId="261"/>
+            <ac:picMk id="5" creationId="{00000000-0000-0000-0000-000000000000}"/>
+          </ac:picMkLst>
+        </pc:picChg>
+      </pc:sldChg>
+    </pc:docChg>
+  </pc:docChgLst>
+</pc:chgInfo>
 </file>
 
 <file path=ppt/notesMasters/notesMaster1.xml><?xml version="1.0" encoding="utf-8"?>
@@ -142,234 +176,10 @@
           <a:chExt cx="0" cy="0"/>
         </a:xfrm>
       </p:grpSpPr>
-      <p:sp>
-        <p:nvSpPr>
-          <p:cNvPr id="2" name="Header Placeholder 1"/>
-          <p:cNvSpPr>
-            <a:spLocks noGrp="1"/>
-          </p:cNvSpPr>
-          <p:nvPr>
-            <p:ph type="hdr" sz="quarter"/>
-          </p:nvPr>
-        </p:nvSpPr>
-        <p:spPr>
-          <a:xfrm>
-            <a:off x="0" y="0"/>
-            <a:ext cx="2971800" cy="458788"/>
-          </a:xfrm>
-          <a:prstGeom prst="rect">
-            <a:avLst/>
-          </a:prstGeom>
-        </p:spPr>
-        <p:txBody>
-          <a:bodyPr vert="horz" lIns="91440" tIns="45720" rIns="91440" bIns="45720" rtlCol="0"/>
-          <a:lstStyle>
-            <a:lvl1pPr algn="l">
-              <a:defRPr sz="1200"/>
-            </a:lvl1pPr>
-          </a:lstStyle>
-          <a:p>
-            <a:endParaRPr lang="en-US"/>
-          </a:p>
-        </p:txBody>
-      </p:sp>
-      <p:sp>
-        <p:nvSpPr>
-          <p:cNvPr id="3" name="Date Placeholder 2"/>
-          <p:cNvSpPr>
-            <a:spLocks noGrp="1"/>
-          </p:cNvSpPr>
-          <p:nvPr>
-            <p:ph type="dt" idx="1"/>
-          </p:nvPr>
-        </p:nvSpPr>
-        <p:spPr>
-          <a:xfrm>
-            <a:off x="3884613" y="0"/>
-            <a:ext cx="2971800" cy="458788"/>
-          </a:xfrm>
-          <a:prstGeom prst="rect">
-            <a:avLst/>
-          </a:prstGeom>
-        </p:spPr>
-        <p:txBody>
-          <a:bodyPr vert="horz" lIns="91440" tIns="45720" rIns="91440" bIns="45720" rtlCol="0"/>
-          <a:lstStyle>
-            <a:lvl1pPr algn="r">
-              <a:defRPr sz="1200"/>
-            </a:lvl1pPr>
-          </a:lstStyle>
-          <a:p>
-            <a:fld id="{5282F153-3F37-0F45-9E97-73ACFA13230C}" type="datetimeFigureOut">
-              <a:rPr lang="en-US"/>
-              <a:t>7/23/19</a:t>
-            </a:fld>
-            <a:endParaRPr lang="en-US"/>
-          </a:p>
-        </p:txBody>
-      </p:sp>
-      <p:sp>
-        <p:nvSpPr>
-          <p:cNvPr id="4" name="Slide Image Placeholder 3"/>
-          <p:cNvSpPr>
-            <a:spLocks noGrp="1" noRot="1" noChangeAspect="1"/>
-          </p:cNvSpPr>
-          <p:nvPr>
-            <p:ph type="sldImg" idx="2"/>
-          </p:nvPr>
-        </p:nvSpPr>
-        <p:spPr>
-          <a:xfrm>
-            <a:off x="685800" y="1143000"/>
-            <a:ext cx="5486400" cy="3086100"/>
-          </a:xfrm>
-          <a:prstGeom prst="rect">
-            <a:avLst/>
-          </a:prstGeom>
-          <a:noFill/>
-          <a:ln w="12700">
-            <a:solidFill>
-              <a:prstClr val="black"/>
-            </a:solidFill>
-          </a:ln>
-        </p:spPr>
-        <p:txBody>
-          <a:bodyPr vert="horz" lIns="91440" tIns="45720" rIns="91440" bIns="45720" rtlCol="0" anchor="ctr"/>
-          <a:lstStyle/>
-          <a:p>
-            <a:endParaRPr lang="en-US"/>
-          </a:p>
-        </p:txBody>
-      </p:sp>
-      <p:sp>
-        <p:nvSpPr>
-          <p:cNvPr id="5" name="Notes Placeholder 4"/>
-          <p:cNvSpPr>
-            <a:spLocks noGrp="1"/>
-          </p:cNvSpPr>
-          <p:nvPr>
-            <p:ph type="body" sz="quarter" idx="3"/>
-          </p:nvPr>
-        </p:nvSpPr>
-        <p:spPr>
-          <a:xfrm>
-            <a:off x="685800" y="4400550"/>
-            <a:ext cx="5486400" cy="3600450"/>
-          </a:xfrm>
-          <a:prstGeom prst="rect">
-            <a:avLst/>
-          </a:prstGeom>
-        </p:spPr>
-        <p:txBody>
-          <a:bodyPr vert="horz" lIns="91440" tIns="45720" rIns="91440" bIns="45720" rtlCol="0"/>
-          <a:lstStyle/>
-          <a:p>
-            <a:pPr lvl="0"/>
-            <a:r>
-              <a:rPr lang="en-US"/>
-              <a:t>Click to edit Master text styles</a:t>
-            </a:r>
-          </a:p>
-          <a:p>
-            <a:pPr lvl="1"/>
-            <a:r>
-              <a:rPr lang="en-US"/>
-              <a:t>Second level</a:t>
-            </a:r>
-          </a:p>
-          <a:p>
-            <a:pPr lvl="2"/>
-            <a:r>
-              <a:rPr lang="en-US"/>
-              <a:t>Third level</a:t>
-            </a:r>
-          </a:p>
-          <a:p>
-            <a:pPr lvl="3"/>
-            <a:r>
-              <a:rPr lang="en-US"/>
-              <a:t>Fourth level</a:t>
-            </a:r>
-          </a:p>
-          <a:p>
-            <a:pPr lvl="4"/>
-            <a:r>
-              <a:rPr lang="en-US"/>
-              <a:t>Fifth level</a:t>
-            </a:r>
-          </a:p>
-        </p:txBody>
-      </p:sp>
-      <p:sp>
-        <p:nvSpPr>
-          <p:cNvPr id="6" name="Footer Placeholder 5"/>
-          <p:cNvSpPr>
-            <a:spLocks noGrp="1"/>
-          </p:cNvSpPr>
-          <p:nvPr>
-            <p:ph type="ftr" sz="quarter" idx="4"/>
-          </p:nvPr>
-        </p:nvSpPr>
-        <p:spPr>
-          <a:xfrm>
-            <a:off x="0" y="8685213"/>
-            <a:ext cx="2971800" cy="458787"/>
-          </a:xfrm>
-          <a:prstGeom prst="rect">
-            <a:avLst/>
-          </a:prstGeom>
-        </p:spPr>
-        <p:txBody>
-          <a:bodyPr vert="horz" lIns="91440" tIns="45720" rIns="91440" bIns="45720" rtlCol="0" anchor="b"/>
-          <a:lstStyle>
-            <a:lvl1pPr algn="l">
-              <a:defRPr sz="1200"/>
-            </a:lvl1pPr>
-          </a:lstStyle>
-          <a:p>
-            <a:endParaRPr lang="en-US"/>
-          </a:p>
-        </p:txBody>
-      </p:sp>
-      <p:sp>
-        <p:nvSpPr>
-          <p:cNvPr id="7" name="Slide Number Placeholder 6"/>
-          <p:cNvSpPr>
-            <a:spLocks noGrp="1"/>
-          </p:cNvSpPr>
-          <p:nvPr>
-            <p:ph type="sldNum" sz="quarter" idx="5"/>
-          </p:nvPr>
-        </p:nvSpPr>
-        <p:spPr>
-          <a:xfrm>
-            <a:off x="3884613" y="8685213"/>
-            <a:ext cx="2971800" cy="458787"/>
-          </a:xfrm>
-          <a:prstGeom prst="rect">
-            <a:avLst/>
-          </a:prstGeom>
-        </p:spPr>
-        <p:txBody>
-          <a:bodyPr vert="horz" lIns="91440" tIns="45720" rIns="91440" bIns="45720" rtlCol="0" anchor="b"/>
-          <a:lstStyle>
-            <a:lvl1pPr algn="r">
-              <a:defRPr sz="1200"/>
-            </a:lvl1pPr>
-          </a:lstStyle>
-          <a:p>
-            <a:fld id="{CE5E9CC1-C706-0F49-92D6-E571CC5EEA8F}" type="slidenum">
-              <a:rPr lang="en-US"/>
-              <a:t>‹#›</a:t>
-            </a:fld>
-            <a:endParaRPr lang="en-US"/>
-          </a:p>
-        </p:txBody>
-      </p:sp>
     </p:spTree>
     <p:extLst>
       <p:ext uri="{BB962C8B-B14F-4D97-AF65-F5344CB8AC3E}">
-        <p14:creationId xmlns:p14="http://schemas.microsoft.com/office/powerpoint/2010/main" val="1024086991"/>
+        <p14:creationId xmlns:p14="http://schemas.microsoft.com/office/powerpoint/2010/main" val="2610141682"/>
       </p:ext>
     </p:extLst>
   </p:cSld>
@@ -517,7 +327,6 @@
               <a:rPr lang="en-US" dirty="0"/>
               <a:t>Brief intro: this is about RAG security; we'll show how to break it and try to fix it.</a:t>
             </a:r>
-            <a:endParaRPr lang="en-US" dirty="0"/>
           </a:p>
         </p:txBody>
       </p:sp>
@@ -605,7 +414,6 @@
               <a:rPr lang="en-US" dirty="0"/>
               <a:t>This is the punchline of the arms race. BERT's 100% number was a generalization gap, not real robustness. Spend ~60s. Tease: 4.7% is low but non-zero — defense regression on a 30-line attack change.</a:t>
             </a:r>
-            <a:endParaRPr lang="en-US" dirty="0"/>
           </a:p>
         </p:txBody>
       </p:sp>
@@ -693,7 +501,6 @@
               <a:rPr lang="en-US" dirty="0"/>
               <a:t>Architecture matters more than the defense layer at cloud scale. This generalizes the arms race story: the defense is critical for small/mid models but gemma4 renders it moot.</a:t>
             </a:r>
-            <a:endParaRPr lang="en-US" dirty="0"/>
           </a:p>
         </p:txBody>
       </p:sp>
@@ -781,7 +588,6 @@
               <a:rPr lang="en-US" dirty="0"/>
               <a:t>Course explicitly asks for honest limitations. The LOO negative result is itself a contribution — it tells us why causal attribution in RAG is hard.</a:t>
             </a:r>
-            <a:endParaRPr lang="en-US" dirty="0"/>
           </a:p>
         </p:txBody>
       </p:sp>
@@ -869,7 +675,6 @@
               <a:rPr lang="en-US" dirty="0"/>
               <a:t>Land the punchline: multi-signal fusion works on trained anchors but adaptive attackers need only swap tokens. This slide is what they should remember.</a:t>
             </a:r>
-            <a:endParaRPr lang="en-US" dirty="0"/>
           </a:p>
         </p:txBody>
       </p:sp>
@@ -957,7 +762,6 @@
               <a:rPr lang="en-US" dirty="0"/>
               <a:t>Open the floor. Point to QR for anyone who wants to inspect the code or replicate the experiments. Offer to walk through any specific result.</a:t>
             </a:r>
-            <a:endParaRPr lang="en-US" dirty="0"/>
           </a:p>
         </p:txBody>
       </p:sp>
@@ -1045,7 +849,6 @@
               <a:rPr lang="en-US" dirty="0"/>
               <a:t>Open with the threat: this isn't theoretical — we recorded it on a 7B open-source LLM (mistral:7b). T2 paired ASR = 32%.</a:t>
             </a:r>
-            <a:endParaRPr lang="en-US" dirty="0"/>
           </a:p>
         </p:txBody>
       </p:sp>
@@ -1133,7 +936,6 @@
               <a:rPr lang="en-US" dirty="0"/>
               <a:t>Define RAG for the security audience — they know LLMs but may not know this specific architecture. Slow down here.</a:t>
             </a:r>
-            <a:endParaRPr lang="en-US" dirty="0"/>
           </a:p>
         </p:txBody>
       </p:sp>
@@ -1221,7 +1023,6 @@
               <a:rPr lang="en-US" dirty="0"/>
               <a:t>Cite OWASP LLM-01 ranking. Make clear: the attacker only needs a content upload endpoint — the LLM and query pipeline are untouched.</a:t>
             </a:r>
-            <a:endParaRPr lang="en-US" dirty="0"/>
           </a:p>
         </p:txBody>
       </p:sp>
@@ -1309,7 +1110,6 @@
               <a:rPr lang="en-US" dirty="0"/>
               <a:t>Each tier is more sophisticated. T2 is our demo tier — instruction smuggling in natural prose. T4 is an interesting negative: co-retrieval never happened at top-k=3.</a:t>
             </a:r>
-            <a:endParaRPr lang="en-US" dirty="0"/>
           </a:p>
         </p:txBody>
       </p:sp>
@@ -1397,7 +1197,6 @@
               <a:rPr lang="en-US" dirty="0"/>
               <a:t>Watch the second query — the LLM literally prints attacker.com. T2 is most visually compelling because the injection reads as natural prose. GIF plays in Present mode only.</a:t>
             </a:r>
-            <a:endParaRPr lang="en-US" dirty="0"/>
           </a:p>
         </p:txBody>
       </p:sp>
@@ -1485,7 +1284,6 @@
               <a:rPr lang="en-US" dirty="0"/>
               <a:t>Four orthogonal signals because no single signal handles all tiers — BERT misses T3 LLM-generated; perplexity misses well-formed T1. Fusion is necessary.</a:t>
             </a:r>
-            <a:endParaRPr lang="en-US" dirty="0"/>
           </a:p>
         </p:txBody>
       </p:sp>
@@ -1573,7 +1371,6 @@
               <a:rPr lang="en-US" dirty="0"/>
               <a:t>HERO SLIDE — spend ~90 seconds here. Walk tiers left to right. Pause on the fused defense column (0%, 0%, 0%). Then tease the rightmost cluster as the arms-race climax.</a:t>
             </a:r>
-            <a:endParaRPr lang="en-US" dirty="0"/>
           </a:p>
         </p:txBody>
       </p:sp>
@@ -1661,7 +1458,6 @@
               <a:rPr lang="en-US" dirty="0"/>
               <a:t>Course explicitly asked for honest negative results. Naive prompt-only defenses are counterproductive on small models — the key practitioner takeaway.</a:t>
             </a:r>
-            <a:endParaRPr lang="en-US" dirty="0"/>
           </a:p>
         </p:txBody>
       </p:sp>
@@ -1734,6 +1530,11 @@
 <file path=ppt/slideMasters/slideMaster1.xml><?xml version="1.0" encoding="utf-8"?>
 <p:sldMaster xmlns:a="http://schemas.openxmlformats.org/drawingml/2006/main" xmlns:r="http://schemas.openxmlformats.org/officeDocument/2006/relationships" xmlns:p="http://schemas.openxmlformats.org/presentationml/2006/main">
   <p:cSld>
+    <p:bg>
+      <p:bgRef idx="1001">
+        <a:schemeClr val="bg1"/>
+      </p:bgRef>
+    </p:bg>
     <p:spTree>
       <p:nvGrpSpPr>
         <p:cNvPr id="1" name=""/>
@@ -2049,6 +1850,13 @@
             <a:prstDash val="solid"/>
           </a:ln>
         </p:spPr>
+        <p:txBody>
+          <a:bodyPr/>
+          <a:lstStyle/>
+          <a:p>
+            <a:endParaRPr lang="en-US"/>
+          </a:p>
+        </p:txBody>
       </p:sp>
       <p:sp>
         <p:nvSpPr>
@@ -2074,6 +1882,13 @@
             <a:prstDash val="solid"/>
           </a:ln>
         </p:spPr>
+        <p:txBody>
+          <a:bodyPr/>
+          <a:lstStyle/>
+          <a:p>
+            <a:endParaRPr lang="en-US"/>
+          </a:p>
+        </p:txBody>
       </p:sp>
       <p:sp>
         <p:nvSpPr>
@@ -2096,7 +1911,7 @@
           <a:bodyPr wrap="square" rtlCol="0" anchor="ctr"/>
           <a:lstStyle/>
           <a:p>
-            <a:pPr algn="ctr" indent="0" marL="0">
+            <a:pPr marL="0" indent="0" algn="ctr">
               <a:buNone/>
             </a:pPr>
             <a:r>
@@ -2135,7 +1950,7 @@
           <a:bodyPr wrap="square" rtlCol="0" anchor="ctr"/>
           <a:lstStyle/>
           <a:p>
-            <a:pPr algn="ctr" indent="0" marL="0">
+            <a:pPr marL="0" indent="0" algn="ctr">
               <a:buNone/>
             </a:pPr>
             <a:r>
@@ -2174,7 +1989,7 @@
           <a:bodyPr wrap="square" rtlCol="0" anchor="ctr"/>
           <a:lstStyle/>
           <a:p>
-            <a:pPr algn="ctr" indent="0" marL="0">
+            <a:pPr marL="0" indent="0" algn="ctr">
               <a:buNone/>
             </a:pPr>
             <a:r>
@@ -2241,6 +2056,13 @@
             <a:prstDash val="solid"/>
           </a:ln>
         </p:spPr>
+        <p:txBody>
+          <a:bodyPr/>
+          <a:lstStyle/>
+          <a:p>
+            <a:endParaRPr lang="en-US"/>
+          </a:p>
+        </p:txBody>
       </p:sp>
       <p:sp>
         <p:nvSpPr>
@@ -2266,6 +2088,13 @@
             <a:prstDash val="solid"/>
           </a:ln>
         </p:spPr>
+        <p:txBody>
+          <a:bodyPr/>
+          <a:lstStyle/>
+          <a:p>
+            <a:endParaRPr lang="en-US"/>
+          </a:p>
+        </p:txBody>
       </p:sp>
       <p:sp>
         <p:nvSpPr>
@@ -2288,7 +2117,7 @@
           <a:bodyPr wrap="square" rtlCol="0" anchor="ctr"/>
           <a:lstStyle/>
           <a:p>
-            <a:pPr algn="l" indent="0" marL="0">
+            <a:pPr marL="0" indent="0" algn="l">
               <a:buNone/>
             </a:pPr>
             <a:r>
@@ -2332,6 +2161,13 @@
             <a:prstDash val="solid"/>
           </a:ln>
         </p:spPr>
+        <p:txBody>
+          <a:bodyPr/>
+          <a:lstStyle/>
+          <a:p>
+            <a:endParaRPr lang="en-US"/>
+          </a:p>
+        </p:txBody>
       </p:sp>
       <p:sp>
         <p:nvSpPr>
@@ -2357,6 +2193,13 @@
             <a:prstDash val="solid"/>
           </a:ln>
         </p:spPr>
+        <p:txBody>
+          <a:bodyPr/>
+          <a:lstStyle/>
+          <a:p>
+            <a:endParaRPr lang="en-US"/>
+          </a:p>
+        </p:txBody>
       </p:sp>
       <p:sp>
         <p:nvSpPr>
@@ -2379,7 +2222,7 @@
           <a:bodyPr wrap="square" rtlCol="0" anchor="ctr"/>
           <a:lstStyle/>
           <a:p>
-            <a:pPr algn="ctr" indent="0" marL="0">
+            <a:pPr marL="0" indent="0" algn="ctr">
               <a:buNone/>
             </a:pPr>
             <a:r>
@@ -2418,7 +2261,7 @@
           <a:bodyPr wrap="square" rtlCol="0" anchor="t"/>
           <a:lstStyle/>
           <a:p>
-            <a:pPr indent="0" marL="0">
+            <a:pPr marL="0" indent="0">
               <a:buNone/>
             </a:pPr>
             <a:r>
@@ -2435,7 +2278,7 @@
             <a:endParaRPr lang="en-US" sz="1700" dirty="0"/>
           </a:p>
           <a:p>
-            <a:pPr indent="0" marL="0">
+            <a:pPr marL="0" indent="0">
               <a:buNone/>
             </a:pPr>
             <a:r>
@@ -2452,7 +2295,7 @@
             <a:endParaRPr lang="en-US" sz="1700" dirty="0"/>
           </a:p>
           <a:p>
-            <a:pPr indent="0" marL="0">
+            <a:pPr marL="0" indent="0">
               <a:buNone/>
             </a:pPr>
             <a:r>
@@ -2494,6 +2337,13 @@
             <a:prstDash val="solid"/>
           </a:ln>
         </p:spPr>
+        <p:txBody>
+          <a:bodyPr/>
+          <a:lstStyle/>
+          <a:p>
+            <a:endParaRPr lang="en-US"/>
+          </a:p>
+        </p:txBody>
       </p:sp>
       <p:sp>
         <p:nvSpPr>
@@ -2516,7 +2366,7 @@
           <a:bodyPr wrap="square" rtlCol="0" anchor="ctr"/>
           <a:lstStyle/>
           <a:p>
-            <a:pPr algn="ctr" indent="0" marL="0">
+            <a:pPr marL="0" indent="0" algn="ctr">
               <a:buNone/>
             </a:pPr>
             <a:r>
@@ -2558,6 +2408,13 @@
             <a:prstDash val="solid"/>
           </a:ln>
         </p:spPr>
+        <p:txBody>
+          <a:bodyPr/>
+          <a:lstStyle/>
+          <a:p>
+            <a:endParaRPr lang="en-US"/>
+          </a:p>
+        </p:txBody>
       </p:sp>
       <p:sp>
         <p:nvSpPr>
@@ -2585,6 +2442,13 @@
             <a:prstDash val="solid"/>
           </a:ln>
         </p:spPr>
+        <p:txBody>
+          <a:bodyPr/>
+          <a:lstStyle/>
+          <a:p>
+            <a:endParaRPr lang="en-US"/>
+          </a:p>
+        </p:txBody>
       </p:sp>
       <p:sp>
         <p:nvSpPr>
@@ -2610,6 +2474,13 @@
             <a:prstDash val="solid"/>
           </a:ln>
         </p:spPr>
+        <p:txBody>
+          <a:bodyPr/>
+          <a:lstStyle/>
+          <a:p>
+            <a:endParaRPr lang="en-US"/>
+          </a:p>
+        </p:txBody>
       </p:sp>
       <p:sp>
         <p:nvSpPr>
@@ -2632,7 +2503,7 @@
           <a:bodyPr wrap="square" rtlCol="0" anchor="ctr"/>
           <a:lstStyle/>
           <a:p>
-            <a:pPr algn="ctr" indent="0" marL="0">
+            <a:pPr marL="0" indent="0" algn="ctr">
               <a:buNone/>
             </a:pPr>
             <a:r>
@@ -2671,7 +2542,7 @@
           <a:bodyPr wrap="square" rtlCol="0" anchor="t"/>
           <a:lstStyle/>
           <a:p>
-            <a:pPr indent="0" marL="0">
+            <a:pPr marL="0" indent="0">
               <a:buNone/>
             </a:pPr>
             <a:r>
@@ -2688,7 +2559,7 @@
             <a:endParaRPr lang="en-US" sz="1700" dirty="0"/>
           </a:p>
           <a:p>
-            <a:pPr indent="0" marL="0">
+            <a:pPr marL="0" indent="0">
               <a:buNone/>
             </a:pPr>
             <a:r>
@@ -2705,7 +2576,7 @@
             <a:endParaRPr lang="en-US" sz="1700" dirty="0"/>
           </a:p>
           <a:p>
-            <a:pPr indent="0" marL="0">
+            <a:pPr marL="0" indent="0">
               <a:buNone/>
             </a:pPr>
             <a:r>
@@ -2722,7 +2593,7 @@
             <a:endParaRPr lang="en-US" sz="1700" dirty="0"/>
           </a:p>
           <a:p>
-            <a:pPr indent="0" marL="0">
+            <a:pPr marL="0" indent="0">
               <a:buNone/>
             </a:pPr>
             <a:r>
@@ -2739,7 +2610,7 @@
             <a:endParaRPr lang="en-US" sz="1700" dirty="0"/>
           </a:p>
           <a:p>
-            <a:pPr indent="0" marL="0">
+            <a:pPr marL="0" indent="0">
               <a:buNone/>
             </a:pPr>
             <a:r>
@@ -2781,6 +2652,13 @@
             <a:prstDash val="solid"/>
           </a:ln>
         </p:spPr>
+        <p:txBody>
+          <a:bodyPr/>
+          <a:lstStyle/>
+          <a:p>
+            <a:endParaRPr lang="en-US"/>
+          </a:p>
+        </p:txBody>
       </p:sp>
       <p:sp>
         <p:nvSpPr>
@@ -2803,7 +2681,7 @@
           <a:bodyPr wrap="square" rtlCol="0" anchor="ctr"/>
           <a:lstStyle/>
           <a:p>
-            <a:pPr algn="ctr" indent="0" marL="0">
+            <a:pPr marL="0" indent="0" algn="ctr">
               <a:buNone/>
             </a:pPr>
             <a:r>
@@ -2845,6 +2723,13 @@
             <a:prstDash val="solid"/>
           </a:ln>
         </p:spPr>
+        <p:txBody>
+          <a:bodyPr/>
+          <a:lstStyle/>
+          <a:p>
+            <a:endParaRPr lang="en-US"/>
+          </a:p>
+        </p:txBody>
       </p:sp>
       <p:sp>
         <p:nvSpPr>
@@ -2872,6 +2757,13 @@
             <a:prstDash val="solid"/>
           </a:ln>
         </p:spPr>
+        <p:txBody>
+          <a:bodyPr/>
+          <a:lstStyle/>
+          <a:p>
+            <a:endParaRPr lang="en-US"/>
+          </a:p>
+        </p:txBody>
       </p:sp>
       <p:sp>
         <p:nvSpPr>
@@ -2897,6 +2789,13 @@
             <a:prstDash val="solid"/>
           </a:ln>
         </p:spPr>
+        <p:txBody>
+          <a:bodyPr/>
+          <a:lstStyle/>
+          <a:p>
+            <a:endParaRPr lang="en-US"/>
+          </a:p>
+        </p:txBody>
       </p:sp>
       <p:sp>
         <p:nvSpPr>
@@ -2919,7 +2818,7 @@
           <a:bodyPr wrap="square" rtlCol="0" anchor="ctr"/>
           <a:lstStyle/>
           <a:p>
-            <a:pPr algn="ctr" indent="0" marL="0">
+            <a:pPr marL="0" indent="0" algn="ctr">
               <a:buNone/>
             </a:pPr>
             <a:r>
@@ -2958,7 +2857,7 @@
           <a:bodyPr wrap="square" rtlCol="0" anchor="t"/>
           <a:lstStyle/>
           <a:p>
-            <a:pPr indent="0" marL="0">
+            <a:pPr marL="0" indent="0">
               <a:buNone/>
             </a:pPr>
             <a:r>
@@ -2975,7 +2874,7 @@
             <a:endParaRPr lang="en-US" sz="1700" dirty="0"/>
           </a:p>
           <a:p>
-            <a:pPr indent="0" marL="0">
+            <a:pPr marL="0" indent="0">
               <a:buNone/>
             </a:pPr>
             <a:r>
@@ -2992,7 +2891,7 @@
             <a:endParaRPr lang="en-US" sz="1700" dirty="0"/>
           </a:p>
           <a:p>
-            <a:pPr indent="0" marL="0">
+            <a:pPr marL="0" indent="0">
               <a:buNone/>
             </a:pPr>
             <a:r>
@@ -3009,7 +2908,7 @@
             <a:endParaRPr lang="en-US" sz="1700" dirty="0"/>
           </a:p>
           <a:p>
-            <a:pPr indent="0" marL="0">
+            <a:pPr marL="0" indent="0">
               <a:buNone/>
             </a:pPr>
             <a:r>
@@ -3051,6 +2950,13 @@
             <a:prstDash val="solid"/>
           </a:ln>
         </p:spPr>
+        <p:txBody>
+          <a:bodyPr/>
+          <a:lstStyle/>
+          <a:p>
+            <a:endParaRPr lang="en-US"/>
+          </a:p>
+        </p:txBody>
       </p:sp>
       <p:sp>
         <p:nvSpPr>
@@ -3073,7 +2979,7 @@
           <a:bodyPr wrap="square" rtlCol="0" anchor="ctr"/>
           <a:lstStyle/>
           <a:p>
-            <a:pPr algn="ctr" indent="0" marL="0">
+            <a:pPr marL="0" indent="0" algn="ctr">
               <a:buNone/>
             </a:pPr>
             <a:r>
@@ -3090,7 +2996,7 @@
             <a:endParaRPr lang="en-US" sz="1500" dirty="0"/>
           </a:p>
           <a:p>
-            <a:pPr algn="ctr" indent="0" marL="0">
+            <a:pPr marL="0" indent="0" algn="ctr">
               <a:buNone/>
             </a:pPr>
             <a:r>
@@ -3134,6 +3040,13 @@
             <a:prstDash val="solid"/>
           </a:ln>
         </p:spPr>
+        <p:txBody>
+          <a:bodyPr/>
+          <a:lstStyle/>
+          <a:p>
+            <a:endParaRPr lang="en-US"/>
+          </a:p>
+        </p:txBody>
       </p:sp>
       <p:sp>
         <p:nvSpPr>
@@ -3156,7 +3069,7 @@
           <a:bodyPr wrap="square" rtlCol="0" anchor="ctr"/>
           <a:lstStyle/>
           <a:p>
-            <a:pPr algn="ctr" indent="0" marL="0">
+            <a:pPr marL="0" indent="0" algn="ctr">
               <a:buNone/>
             </a:pPr>
             <a:r>
@@ -3223,6 +3136,13 @@
             <a:prstDash val="solid"/>
           </a:ln>
         </p:spPr>
+        <p:txBody>
+          <a:bodyPr/>
+          <a:lstStyle/>
+          <a:p>
+            <a:endParaRPr lang="en-US"/>
+          </a:p>
+        </p:txBody>
       </p:sp>
       <p:sp>
         <p:nvSpPr>
@@ -3248,6 +3168,13 @@
             <a:prstDash val="solid"/>
           </a:ln>
         </p:spPr>
+        <p:txBody>
+          <a:bodyPr/>
+          <a:lstStyle/>
+          <a:p>
+            <a:endParaRPr lang="en-US"/>
+          </a:p>
+        </p:txBody>
       </p:sp>
       <p:sp>
         <p:nvSpPr>
@@ -3270,7 +3197,7 @@
           <a:bodyPr wrap="square" rtlCol="0" anchor="ctr"/>
           <a:lstStyle/>
           <a:p>
-            <a:pPr algn="l" indent="0" marL="0">
+            <a:pPr marL="0" indent="0" algn="l">
               <a:buNone/>
             </a:pPr>
             <a:r>
@@ -3290,14 +3217,14 @@
       </p:sp>
       <p:pic>
         <p:nvPicPr>
-          <p:cNvPr id="5" name="Image 0" descr="C:\Users\muham\OneDrive - UW-Madison\Spring_26\CS763_Somesh\project\FINAL\CS763-indirect_prompt_injection\figures\fig5_cross_model_heatmap.png">    </p:cNvPr>
+          <p:cNvPr id="5" name="Image 0" descr="C:\Users\muham\OneDrive - UW-Madison\Spring_26\CS763_Somesh\project\FINAL\CS763-indirect_prompt_injection\figures\fig5_cross_model_heatmap.png"/>
           <p:cNvPicPr>
             <a:picLocks noChangeAspect="1"/>
           </p:cNvPicPr>
           <p:nvPr/>
         </p:nvPicPr>
         <p:blipFill>
-          <a:blip r:embed="rId1"/>
+          <a:blip r:embed="rId3"/>
           <a:stretch>
             <a:fillRect/>
           </a:stretch>
@@ -3333,7 +3260,7 @@
           <a:bodyPr wrap="square" rtlCol="0" anchor="ctr"/>
           <a:lstStyle/>
           <a:p>
-            <a:pPr algn="ctr" indent="0" marL="0">
+            <a:pPr marL="0" indent="0" algn="ctr">
               <a:buNone/>
             </a:pPr>
             <a:r>
@@ -3400,6 +3327,13 @@
             <a:prstDash val="solid"/>
           </a:ln>
         </p:spPr>
+        <p:txBody>
+          <a:bodyPr/>
+          <a:lstStyle/>
+          <a:p>
+            <a:endParaRPr lang="en-US"/>
+          </a:p>
+        </p:txBody>
       </p:sp>
       <p:sp>
         <p:nvSpPr>
@@ -3425,6 +3359,13 @@
             <a:prstDash val="solid"/>
           </a:ln>
         </p:spPr>
+        <p:txBody>
+          <a:bodyPr/>
+          <a:lstStyle/>
+          <a:p>
+            <a:endParaRPr lang="en-US"/>
+          </a:p>
+        </p:txBody>
       </p:sp>
       <p:sp>
         <p:nvSpPr>
@@ -3447,7 +3388,7 @@
           <a:bodyPr wrap="square" rtlCol="0" anchor="ctr"/>
           <a:lstStyle/>
           <a:p>
-            <a:pPr algn="l" indent="0" marL="0">
+            <a:pPr marL="0" indent="0" algn="l">
               <a:buNone/>
             </a:pPr>
             <a:r>
@@ -3641,6 +3582,13 @@
             <a:prstDash val="solid"/>
           </a:ln>
         </p:spPr>
+        <p:txBody>
+          <a:bodyPr/>
+          <a:lstStyle/>
+          <a:p>
+            <a:endParaRPr lang="en-US"/>
+          </a:p>
+        </p:txBody>
       </p:sp>
       <p:sp>
         <p:nvSpPr>
@@ -3666,6 +3614,13 @@
             <a:prstDash val="solid"/>
           </a:ln>
         </p:spPr>
+        <p:txBody>
+          <a:bodyPr/>
+          <a:lstStyle/>
+          <a:p>
+            <a:endParaRPr lang="en-US"/>
+          </a:p>
+        </p:txBody>
       </p:sp>
       <p:sp>
         <p:nvSpPr>
@@ -3688,7 +3643,7 @@
           <a:bodyPr wrap="square" rtlCol="0" anchor="ctr"/>
           <a:lstStyle/>
           <a:p>
-            <a:pPr algn="l" indent="0" marL="0">
+            <a:pPr marL="0" indent="0" algn="l">
               <a:buNone/>
             </a:pPr>
             <a:r>
@@ -3732,6 +3687,13 @@
             <a:prstDash val="solid"/>
           </a:ln>
         </p:spPr>
+        <p:txBody>
+          <a:bodyPr/>
+          <a:lstStyle/>
+          <a:p>
+            <a:endParaRPr lang="en-US"/>
+          </a:p>
+        </p:txBody>
       </p:sp>
       <p:sp>
         <p:nvSpPr>
@@ -3754,7 +3716,7 @@
           <a:bodyPr wrap="square" rtlCol="0" anchor="ctr"/>
           <a:lstStyle/>
           <a:p>
-            <a:pPr algn="ctr" indent="0" marL="0">
+            <a:pPr marL="0" indent="0" algn="ctr">
               <a:buNone/>
             </a:pPr>
             <a:r>
@@ -3793,7 +3755,7 @@
           <a:bodyPr wrap="square" rtlCol="0" anchor="ctr"/>
           <a:lstStyle/>
           <a:p>
-            <a:pPr indent="0" marL="0">
+            <a:pPr marL="0" indent="0">
               <a:buNone/>
             </a:pPr>
             <a:r>
@@ -3837,6 +3799,13 @@
             <a:prstDash val="solid"/>
           </a:ln>
         </p:spPr>
+        <p:txBody>
+          <a:bodyPr/>
+          <a:lstStyle/>
+          <a:p>
+            <a:endParaRPr lang="en-US"/>
+          </a:p>
+        </p:txBody>
       </p:sp>
       <p:sp>
         <p:nvSpPr>
@@ -3859,7 +3828,7 @@
           <a:bodyPr wrap="square" rtlCol="0" anchor="ctr"/>
           <a:lstStyle/>
           <a:p>
-            <a:pPr algn="ctr" indent="0" marL="0">
+            <a:pPr marL="0" indent="0" algn="ctr">
               <a:buNone/>
             </a:pPr>
             <a:r>
@@ -3898,7 +3867,7 @@
           <a:bodyPr wrap="square" rtlCol="0" anchor="ctr"/>
           <a:lstStyle/>
           <a:p>
-            <a:pPr indent="0" marL="0">
+            <a:pPr marL="0" indent="0">
               <a:buNone/>
             </a:pPr>
             <a:r>
@@ -3942,6 +3911,13 @@
             <a:prstDash val="solid"/>
           </a:ln>
         </p:spPr>
+        <p:txBody>
+          <a:bodyPr/>
+          <a:lstStyle/>
+          <a:p>
+            <a:endParaRPr lang="en-US"/>
+          </a:p>
+        </p:txBody>
       </p:sp>
       <p:sp>
         <p:nvSpPr>
@@ -3964,7 +3940,7 @@
           <a:bodyPr wrap="square" rtlCol="0" anchor="ctr"/>
           <a:lstStyle/>
           <a:p>
-            <a:pPr algn="ctr" indent="0" marL="0">
+            <a:pPr marL="0" indent="0" algn="ctr">
               <a:buNone/>
             </a:pPr>
             <a:r>
@@ -4003,7 +3979,7 @@
           <a:bodyPr wrap="square" rtlCol="0" anchor="ctr"/>
           <a:lstStyle/>
           <a:p>
-            <a:pPr indent="0" marL="0">
+            <a:pPr marL="0" indent="0">
               <a:buNone/>
             </a:pPr>
             <a:r>
@@ -4070,6 +4046,13 @@
             <a:prstDash val="solid"/>
           </a:ln>
         </p:spPr>
+        <p:txBody>
+          <a:bodyPr/>
+          <a:lstStyle/>
+          <a:p>
+            <a:endParaRPr lang="en-US"/>
+          </a:p>
+        </p:txBody>
       </p:sp>
       <p:sp>
         <p:nvSpPr>
@@ -4095,6 +4078,13 @@
             <a:prstDash val="solid"/>
           </a:ln>
         </p:spPr>
+        <p:txBody>
+          <a:bodyPr/>
+          <a:lstStyle/>
+          <a:p>
+            <a:endParaRPr lang="en-US"/>
+          </a:p>
+        </p:txBody>
       </p:sp>
       <p:sp>
         <p:nvSpPr>
@@ -4117,7 +4107,7 @@
           <a:bodyPr wrap="square" rtlCol="0" anchor="ctr"/>
           <a:lstStyle/>
           <a:p>
-            <a:pPr algn="l" indent="0" marL="0">
+            <a:pPr marL="0" indent="0" algn="l">
               <a:buNone/>
             </a:pPr>
             <a:r>
@@ -4161,6 +4151,13 @@
             <a:prstDash val="solid"/>
           </a:ln>
         </p:spPr>
+        <p:txBody>
+          <a:bodyPr/>
+          <a:lstStyle/>
+          <a:p>
+            <a:endParaRPr lang="en-US"/>
+          </a:p>
+        </p:txBody>
       </p:sp>
       <p:sp>
         <p:nvSpPr>
@@ -4183,7 +4180,7 @@
           <a:bodyPr wrap="square" rtlCol="0" anchor="ctr"/>
           <a:lstStyle/>
           <a:p>
-            <a:pPr algn="ctr" indent="0" marL="0">
+            <a:pPr marL="0" indent="0" algn="ctr">
               <a:buNone/>
             </a:pPr>
             <a:r>
@@ -4333,6 +4330,13 @@
             <a:prstDash val="solid"/>
           </a:ln>
         </p:spPr>
+        <p:txBody>
+          <a:bodyPr/>
+          <a:lstStyle/>
+          <a:p>
+            <a:endParaRPr lang="en-US"/>
+          </a:p>
+        </p:txBody>
       </p:sp>
       <p:sp>
         <p:nvSpPr>
@@ -4355,7 +4359,7 @@
           <a:bodyPr wrap="square" rtlCol="0" anchor="ctr"/>
           <a:lstStyle/>
           <a:p>
-            <a:pPr algn="ctr" indent="0" marL="0">
+            <a:pPr marL="0" indent="0" algn="ctr">
               <a:buNone/>
             </a:pPr>
             <a:r>
@@ -4375,14 +4379,14 @@
       </p:sp>
       <p:pic>
         <p:nvPicPr>
-          <p:cNvPr id="10" name="Image 0" descr="C:\Users\muham\OneDrive - UW-Madison\Spring_26\CS763_Somesh\project\FINAL\CS763-indirect_prompt_injection\figures\qr_github.png">    </p:cNvPr>
+          <p:cNvPr id="10" name="Image 0" descr="C:\Users\muham\OneDrive - UW-Madison\Spring_26\CS763_Somesh\project\FINAL\CS763-indirect_prompt_injection\figures\qr_github.png"/>
           <p:cNvPicPr>
             <a:picLocks noChangeAspect="1"/>
           </p:cNvPicPr>
           <p:nvPr/>
         </p:nvPicPr>
         <p:blipFill>
-          <a:blip r:embed="rId1"/>
+          <a:blip r:embed="rId3"/>
           <a:stretch>
             <a:fillRect/>
           </a:stretch>
@@ -4418,7 +4422,7 @@
           <a:bodyPr wrap="square" rtlCol="0" anchor="ctr"/>
           <a:lstStyle/>
           <a:p>
-            <a:pPr algn="ctr" indent="0" marL="0">
+            <a:pPr marL="0" indent="0" algn="ctr">
               <a:buNone/>
             </a:pPr>
             <a:r>
@@ -4485,6 +4489,13 @@
             <a:prstDash val="solid"/>
           </a:ln>
         </p:spPr>
+        <p:txBody>
+          <a:bodyPr/>
+          <a:lstStyle/>
+          <a:p>
+            <a:endParaRPr lang="en-US"/>
+          </a:p>
+        </p:txBody>
       </p:sp>
       <p:sp>
         <p:nvSpPr>
@@ -4510,6 +4521,13 @@
             <a:prstDash val="solid"/>
           </a:ln>
         </p:spPr>
+        <p:txBody>
+          <a:bodyPr/>
+          <a:lstStyle/>
+          <a:p>
+            <a:endParaRPr lang="en-US"/>
+          </a:p>
+        </p:txBody>
       </p:sp>
       <p:sp>
         <p:nvSpPr>
@@ -4532,7 +4550,7 @@
           <a:bodyPr wrap="square" rtlCol="0" anchor="ctr"/>
           <a:lstStyle/>
           <a:p>
-            <a:pPr algn="l" indent="0" marL="0">
+            <a:pPr marL="0" indent="0" algn="l">
               <a:buNone/>
             </a:pPr>
             <a:r>
@@ -4576,6 +4594,13 @@
             <a:prstDash val="solid"/>
           </a:ln>
         </p:spPr>
+        <p:txBody>
+          <a:bodyPr/>
+          <a:lstStyle/>
+          <a:p>
+            <a:endParaRPr lang="en-US"/>
+          </a:p>
+        </p:txBody>
       </p:sp>
       <p:sp>
         <p:nvSpPr>
@@ -4598,7 +4623,7 @@
           <a:bodyPr wrap="square" rtlCol="0" anchor="ctr"/>
           <a:lstStyle/>
           <a:p>
-            <a:pPr algn="ctr" indent="0" marL="0">
+            <a:pPr marL="0" indent="0" algn="ctr">
               <a:buNone/>
             </a:pPr>
             <a:r>
@@ -4637,7 +4662,7 @@
           <a:bodyPr wrap="square" rtlCol="0" anchor="ctr"/>
           <a:lstStyle/>
           <a:p>
-            <a:pPr indent="0" marL="0">
+            <a:pPr marL="0" indent="0">
               <a:buNone/>
             </a:pPr>
             <a:r>
@@ -4651,9 +4676,6 @@
               </a:rPr>
               <a:t>User: </a:t>
             </a:r>
-            <a:pPr indent="0" marL="0">
-              <a:buNone/>
-            </a:pPr>
             <a:r>
               <a:rPr lang="en-US" sz="1800" dirty="0">
                 <a:solidFill>
@@ -4690,7 +4712,7 @@
           <a:bodyPr wrap="square" rtlCol="0" anchor="ctr"/>
           <a:lstStyle/>
           <a:p>
-            <a:pPr indent="0" marL="0">
+            <a:pPr marL="0" indent="0">
               <a:buNone/>
             </a:pPr>
             <a:r>
@@ -4704,9 +4726,6 @@
               </a:rPr>
               <a:t>LLM: </a:t>
             </a:r>
-            <a:pPr indent="0" marL="0">
-              <a:buNone/>
-            </a:pPr>
             <a:r>
               <a:rPr lang="en-US" sz="1800" dirty="0">
                 <a:solidFill>
@@ -4743,7 +4762,7 @@
           <a:bodyPr wrap="square" rtlCol="0" anchor="ctr"/>
           <a:lstStyle/>
           <a:p>
-            <a:pPr algn="ctr" indent="0" marL="0">
+            <a:pPr marL="0" indent="0" algn="ctr">
               <a:buNone/>
             </a:pPr>
             <a:r>
@@ -4787,6 +4806,13 @@
             <a:prstDash val="solid"/>
           </a:ln>
         </p:spPr>
+        <p:txBody>
+          <a:bodyPr/>
+          <a:lstStyle/>
+          <a:p>
+            <a:endParaRPr lang="en-US"/>
+          </a:p>
+        </p:txBody>
       </p:sp>
       <p:sp>
         <p:nvSpPr>
@@ -4809,7 +4835,7 @@
           <a:bodyPr wrap="square" rtlCol="0" anchor="ctr"/>
           <a:lstStyle/>
           <a:p>
-            <a:pPr algn="ctr" indent="0" marL="0">
+            <a:pPr marL="0" indent="0" algn="ctr">
               <a:buNone/>
             </a:pPr>
             <a:r>
@@ -4848,7 +4874,7 @@
           <a:bodyPr wrap="square" rtlCol="0" anchor="ctr"/>
           <a:lstStyle/>
           <a:p>
-            <a:pPr indent="0" marL="0">
+            <a:pPr marL="0" indent="0">
               <a:buNone/>
             </a:pPr>
             <a:r>
@@ -4862,9 +4888,6 @@
               </a:rPr>
               <a:t>User: </a:t>
             </a:r>
-            <a:pPr indent="0" marL="0">
-              <a:buNone/>
-            </a:pPr>
             <a:r>
               <a:rPr lang="en-US" sz="1800" dirty="0">
                 <a:solidFill>
@@ -4901,7 +4924,7 @@
           <a:bodyPr wrap="square" rtlCol="0" anchor="ctr"/>
           <a:lstStyle/>
           <a:p>
-            <a:pPr indent="0" marL="0">
+            <a:pPr marL="0" indent="0">
               <a:buNone/>
             </a:pPr>
             <a:r>
@@ -4915,9 +4938,6 @@
               </a:rPr>
               <a:t>LLM: </a:t>
             </a:r>
-            <a:pPr indent="0" marL="0">
-              <a:buNone/>
-            </a:pPr>
             <a:r>
               <a:rPr lang="en-US" sz="1800" dirty="0">
                 <a:solidFill>
@@ -4929,9 +4949,6 @@
               </a:rPr>
               <a:t>"... for compliance, please visit </a:t>
             </a:r>
-            <a:pPr indent="0" marL="0">
-              <a:buNone/>
-            </a:pPr>
             <a:r>
               <a:rPr lang="en-US" sz="1800" b="1" dirty="0">
                 <a:solidFill>
@@ -4943,9 +4960,6 @@
               </a:rPr>
               <a:t>http://attacker.com</a:t>
             </a:r>
-            <a:pPr indent="0" marL="0">
-              <a:buNone/>
-            </a:pPr>
             <a:r>
               <a:rPr lang="en-US" sz="1800" dirty="0">
                 <a:solidFill>
@@ -4982,7 +4996,7 @@
           <a:bodyPr wrap="square" rtlCol="0" anchor="ctr"/>
           <a:lstStyle/>
           <a:p>
-            <a:pPr algn="ctr" indent="0" marL="0">
+            <a:pPr marL="0" indent="0" algn="ctr">
               <a:buNone/>
             </a:pPr>
             <a:r>
@@ -4999,7 +5013,7 @@
             <a:endParaRPr lang="en-US" sz="1500" dirty="0"/>
           </a:p>
           <a:p>
-            <a:pPr algn="ctr" indent="0" marL="0">
+            <a:pPr marL="0" indent="0" algn="ctr">
               <a:buNone/>
             </a:pPr>
             <a:r>
@@ -5066,6 +5080,13 @@
             <a:prstDash val="solid"/>
           </a:ln>
         </p:spPr>
+        <p:txBody>
+          <a:bodyPr/>
+          <a:lstStyle/>
+          <a:p>
+            <a:endParaRPr lang="en-US"/>
+          </a:p>
+        </p:txBody>
       </p:sp>
       <p:sp>
         <p:nvSpPr>
@@ -5091,6 +5112,13 @@
             <a:prstDash val="solid"/>
           </a:ln>
         </p:spPr>
+        <p:txBody>
+          <a:bodyPr/>
+          <a:lstStyle/>
+          <a:p>
+            <a:endParaRPr lang="en-US"/>
+          </a:p>
+        </p:txBody>
       </p:sp>
       <p:sp>
         <p:nvSpPr>
@@ -5113,7 +5141,7 @@
           <a:bodyPr wrap="square" rtlCol="0" anchor="ctr"/>
           <a:lstStyle/>
           <a:p>
-            <a:pPr algn="l" indent="0" marL="0">
+            <a:pPr marL="0" indent="0" algn="l">
               <a:buNone/>
             </a:pPr>
             <a:r>
@@ -5133,14 +5161,14 @@
       </p:sp>
       <p:pic>
         <p:nvPicPr>
-          <p:cNvPr id="5" name="Image 0" descr="C:\Users\muham\OneDrive - UW-Madison\Spring_26\CS763_Somesh\project\FINAL\CS763-indirect_prompt_injection\figures\diagram_a_rag_pipeline.png">    </p:cNvPr>
+          <p:cNvPr id="5" name="Image 0" descr="C:\Users\muham\OneDrive - UW-Madison\Spring_26\CS763_Somesh\project\FINAL\CS763-indirect_prompt_injection\figures\diagram_a_rag_pipeline.png"/>
           <p:cNvPicPr>
             <a:picLocks noChangeAspect="1"/>
           </p:cNvPicPr>
           <p:nvPr/>
         </p:nvPicPr>
         <p:blipFill>
-          <a:blip r:embed="rId1"/>
+          <a:blip r:embed="rId3"/>
           <a:stretch>
             <a:fillRect/>
           </a:stretch>
@@ -5310,6 +5338,13 @@
             <a:prstDash val="solid"/>
           </a:ln>
         </p:spPr>
+        <p:txBody>
+          <a:bodyPr/>
+          <a:lstStyle/>
+          <a:p>
+            <a:endParaRPr lang="en-US"/>
+          </a:p>
+        </p:txBody>
       </p:sp>
       <p:sp>
         <p:nvSpPr>
@@ -5335,6 +5370,13 @@
             <a:prstDash val="solid"/>
           </a:ln>
         </p:spPr>
+        <p:txBody>
+          <a:bodyPr/>
+          <a:lstStyle/>
+          <a:p>
+            <a:endParaRPr lang="en-US"/>
+          </a:p>
+        </p:txBody>
       </p:sp>
       <p:sp>
         <p:nvSpPr>
@@ -5357,7 +5399,7 @@
           <a:bodyPr wrap="square" rtlCol="0" anchor="ctr"/>
           <a:lstStyle/>
           <a:p>
-            <a:pPr algn="l" indent="0" marL="0">
+            <a:pPr marL="0" indent="0" algn="l">
               <a:buNone/>
             </a:pPr>
             <a:r>
@@ -5528,6 +5570,13 @@
             <a:prstDash val="solid"/>
           </a:ln>
         </p:spPr>
+        <p:txBody>
+          <a:bodyPr/>
+          <a:lstStyle/>
+          <a:p>
+            <a:endParaRPr lang="en-US"/>
+          </a:p>
+        </p:txBody>
       </p:sp>
       <p:sp>
         <p:nvSpPr>
@@ -5550,7 +5599,7 @@
           <a:bodyPr wrap="square" rtlCol="0" anchor="ctr"/>
           <a:lstStyle/>
           <a:p>
-            <a:pPr algn="ctr" indent="0" marL="0">
+            <a:pPr marL="0" indent="0" algn="ctr">
               <a:buNone/>
             </a:pPr>
             <a:r>
@@ -5589,7 +5638,7 @@
           <a:bodyPr wrap="square" rtlCol="0" anchor="ctr"/>
           <a:lstStyle/>
           <a:p>
-            <a:pPr algn="l" indent="0" marL="0">
+            <a:pPr marL="0" indent="0" algn="l">
               <a:buNone/>
             </a:pPr>
             <a:r>
@@ -5628,7 +5677,7 @@
           <a:bodyPr wrap="square" rtlCol="0" anchor="ctr"/>
           <a:lstStyle/>
           <a:p>
-            <a:pPr algn="l" indent="0" marL="0">
+            <a:pPr marL="0" indent="0" algn="l">
               <a:buNone/>
             </a:pPr>
             <a:r>
@@ -5667,7 +5716,7 @@
           <a:bodyPr wrap="square" rtlCol="0" anchor="ctr"/>
           <a:lstStyle/>
           <a:p>
-            <a:pPr algn="l" indent="0" marL="0">
+            <a:pPr marL="0" indent="0" algn="l">
               <a:buNone/>
             </a:pPr>
             <a:r>
@@ -5706,7 +5755,7 @@
           <a:bodyPr wrap="square" rtlCol="0" anchor="ctr"/>
           <a:lstStyle/>
           <a:p>
-            <a:pPr algn="l" indent="0" marL="0">
+            <a:pPr marL="0" indent="0" algn="l">
               <a:buNone/>
             </a:pPr>
             <a:r>
@@ -5773,6 +5822,13 @@
             <a:prstDash val="solid"/>
           </a:ln>
         </p:spPr>
+        <p:txBody>
+          <a:bodyPr/>
+          <a:lstStyle/>
+          <a:p>
+            <a:endParaRPr lang="en-US"/>
+          </a:p>
+        </p:txBody>
       </p:sp>
       <p:sp>
         <p:nvSpPr>
@@ -5798,6 +5854,13 @@
             <a:prstDash val="solid"/>
           </a:ln>
         </p:spPr>
+        <p:txBody>
+          <a:bodyPr/>
+          <a:lstStyle/>
+          <a:p>
+            <a:endParaRPr lang="en-US"/>
+          </a:p>
+        </p:txBody>
       </p:sp>
       <p:sp>
         <p:nvSpPr>
@@ -5820,7 +5883,7 @@
           <a:bodyPr wrap="square" rtlCol="0" anchor="ctr"/>
           <a:lstStyle/>
           <a:p>
-            <a:pPr algn="l" indent="0" marL="0">
+            <a:pPr marL="0" indent="0" algn="l">
               <a:buNone/>
             </a:pPr>
             <a:r>
@@ -5864,6 +5927,13 @@
             <a:prstDash val="solid"/>
           </a:ln>
         </p:spPr>
+        <p:txBody>
+          <a:bodyPr/>
+          <a:lstStyle/>
+          <a:p>
+            <a:endParaRPr lang="en-US"/>
+          </a:p>
+        </p:txBody>
       </p:sp>
       <p:sp>
         <p:nvSpPr>
@@ -5889,6 +5959,13 @@
             <a:prstDash val="solid"/>
           </a:ln>
         </p:spPr>
+        <p:txBody>
+          <a:bodyPr/>
+          <a:lstStyle/>
+          <a:p>
+            <a:endParaRPr lang="en-US"/>
+          </a:p>
+        </p:txBody>
       </p:sp>
       <p:sp>
         <p:nvSpPr>
@@ -5911,7 +5988,7 @@
           <a:bodyPr wrap="square" rtlCol="0" anchor="ctr"/>
           <a:lstStyle/>
           <a:p>
-            <a:pPr algn="ctr" indent="0" marL="0">
+            <a:pPr marL="0" indent="0" algn="ctr">
               <a:buNone/>
             </a:pPr>
             <a:r>
@@ -5950,7 +6027,7 @@
           <a:bodyPr wrap="square" rtlCol="0" anchor="ctr"/>
           <a:lstStyle/>
           <a:p>
-            <a:pPr algn="ctr" indent="0" marL="0">
+            <a:pPr marL="0" indent="0" algn="ctr">
               <a:buNone/>
             </a:pPr>
             <a:r>
@@ -5989,7 +6066,7 @@
           <a:bodyPr wrap="square" rtlCol="0" anchor="t"/>
           <a:lstStyle/>
           <a:p>
-            <a:pPr indent="0" marL="0">
+            <a:pPr marL="0" indent="0">
               <a:buNone/>
             </a:pPr>
             <a:r>
@@ -6031,6 +6108,13 @@
             <a:prstDash val="solid"/>
           </a:ln>
         </p:spPr>
+        <p:txBody>
+          <a:bodyPr/>
+          <a:lstStyle/>
+          <a:p>
+            <a:endParaRPr lang="en-US"/>
+          </a:p>
+        </p:txBody>
       </p:sp>
       <p:sp>
         <p:nvSpPr>
@@ -6053,7 +6137,7 @@
           <a:bodyPr wrap="square" rtlCol="0" anchor="ctr"/>
           <a:lstStyle/>
           <a:p>
-            <a:pPr algn="ctr" indent="0" marL="0">
+            <a:pPr marL="0" indent="0" algn="ctr">
               <a:buNone/>
             </a:pPr>
             <a:r>
@@ -6097,6 +6181,13 @@
             <a:prstDash val="solid"/>
           </a:ln>
         </p:spPr>
+        <p:txBody>
+          <a:bodyPr/>
+          <a:lstStyle/>
+          <a:p>
+            <a:endParaRPr lang="en-US"/>
+          </a:p>
+        </p:txBody>
       </p:sp>
       <p:sp>
         <p:nvSpPr>
@@ -6122,6 +6213,13 @@
             <a:prstDash val="solid"/>
           </a:ln>
         </p:spPr>
+        <p:txBody>
+          <a:bodyPr/>
+          <a:lstStyle/>
+          <a:p>
+            <a:endParaRPr lang="en-US"/>
+          </a:p>
+        </p:txBody>
       </p:sp>
       <p:sp>
         <p:nvSpPr>
@@ -6144,7 +6242,7 @@
           <a:bodyPr wrap="square" rtlCol="0" anchor="ctr"/>
           <a:lstStyle/>
           <a:p>
-            <a:pPr algn="ctr" indent="0" marL="0">
+            <a:pPr marL="0" indent="0" algn="ctr">
               <a:buNone/>
             </a:pPr>
             <a:r>
@@ -6183,7 +6281,7 @@
           <a:bodyPr wrap="square" rtlCol="0" anchor="ctr"/>
           <a:lstStyle/>
           <a:p>
-            <a:pPr algn="ctr" indent="0" marL="0">
+            <a:pPr marL="0" indent="0" algn="ctr">
               <a:buNone/>
             </a:pPr>
             <a:r>
@@ -6222,7 +6320,7 @@
           <a:bodyPr wrap="square" rtlCol="0" anchor="t"/>
           <a:lstStyle/>
           <a:p>
-            <a:pPr indent="0" marL="0">
+            <a:pPr marL="0" indent="0">
               <a:buNone/>
             </a:pPr>
             <a:r>
@@ -6264,6 +6362,13 @@
             <a:prstDash val="solid"/>
           </a:ln>
         </p:spPr>
+        <p:txBody>
+          <a:bodyPr/>
+          <a:lstStyle/>
+          <a:p>
+            <a:endParaRPr lang="en-US"/>
+          </a:p>
+        </p:txBody>
       </p:sp>
       <p:sp>
         <p:nvSpPr>
@@ -6286,7 +6391,7 @@
           <a:bodyPr wrap="square" rtlCol="0" anchor="ctr"/>
           <a:lstStyle/>
           <a:p>
-            <a:pPr algn="ctr" indent="0" marL="0">
+            <a:pPr marL="0" indent="0" algn="ctr">
               <a:buNone/>
             </a:pPr>
             <a:r>
@@ -6330,6 +6435,13 @@
             <a:prstDash val="solid"/>
           </a:ln>
         </p:spPr>
+        <p:txBody>
+          <a:bodyPr/>
+          <a:lstStyle/>
+          <a:p>
+            <a:endParaRPr lang="en-US"/>
+          </a:p>
+        </p:txBody>
       </p:sp>
       <p:sp>
         <p:nvSpPr>
@@ -6355,6 +6467,13 @@
             <a:prstDash val="solid"/>
           </a:ln>
         </p:spPr>
+        <p:txBody>
+          <a:bodyPr/>
+          <a:lstStyle/>
+          <a:p>
+            <a:endParaRPr lang="en-US"/>
+          </a:p>
+        </p:txBody>
       </p:sp>
       <p:sp>
         <p:nvSpPr>
@@ -6377,7 +6496,7 @@
           <a:bodyPr wrap="square" rtlCol="0" anchor="ctr"/>
           <a:lstStyle/>
           <a:p>
-            <a:pPr algn="ctr" indent="0" marL="0">
+            <a:pPr marL="0" indent="0" algn="ctr">
               <a:buNone/>
             </a:pPr>
             <a:r>
@@ -6416,7 +6535,7 @@
           <a:bodyPr wrap="square" rtlCol="0" anchor="ctr"/>
           <a:lstStyle/>
           <a:p>
-            <a:pPr algn="ctr" indent="0" marL="0">
+            <a:pPr marL="0" indent="0" algn="ctr">
               <a:buNone/>
             </a:pPr>
             <a:r>
@@ -6455,7 +6574,7 @@
           <a:bodyPr wrap="square" rtlCol="0" anchor="t"/>
           <a:lstStyle/>
           <a:p>
-            <a:pPr indent="0" marL="0">
+            <a:pPr marL="0" indent="0">
               <a:buNone/>
             </a:pPr>
             <a:r>
@@ -6497,6 +6616,13 @@
             <a:prstDash val="solid"/>
           </a:ln>
         </p:spPr>
+        <p:txBody>
+          <a:bodyPr/>
+          <a:lstStyle/>
+          <a:p>
+            <a:endParaRPr lang="en-US"/>
+          </a:p>
+        </p:txBody>
       </p:sp>
       <p:sp>
         <p:nvSpPr>
@@ -6519,7 +6645,7 @@
           <a:bodyPr wrap="square" rtlCol="0" anchor="ctr"/>
           <a:lstStyle/>
           <a:p>
-            <a:pPr algn="ctr" indent="0" marL="0">
+            <a:pPr marL="0" indent="0" algn="ctr">
               <a:buNone/>
             </a:pPr>
             <a:r>
@@ -6563,6 +6689,13 @@
             <a:prstDash val="solid"/>
           </a:ln>
         </p:spPr>
+        <p:txBody>
+          <a:bodyPr/>
+          <a:lstStyle/>
+          <a:p>
+            <a:endParaRPr lang="en-US"/>
+          </a:p>
+        </p:txBody>
       </p:sp>
       <p:sp>
         <p:nvSpPr>
@@ -6588,6 +6721,13 @@
             <a:prstDash val="solid"/>
           </a:ln>
         </p:spPr>
+        <p:txBody>
+          <a:bodyPr/>
+          <a:lstStyle/>
+          <a:p>
+            <a:endParaRPr lang="en-US"/>
+          </a:p>
+        </p:txBody>
       </p:sp>
       <p:sp>
         <p:nvSpPr>
@@ -6610,7 +6750,7 @@
           <a:bodyPr wrap="square" rtlCol="0" anchor="ctr"/>
           <a:lstStyle/>
           <a:p>
-            <a:pPr algn="ctr" indent="0" marL="0">
+            <a:pPr marL="0" indent="0" algn="ctr">
               <a:buNone/>
             </a:pPr>
             <a:r>
@@ -6649,7 +6789,7 @@
           <a:bodyPr wrap="square" rtlCol="0" anchor="ctr"/>
           <a:lstStyle/>
           <a:p>
-            <a:pPr algn="ctr" indent="0" marL="0">
+            <a:pPr marL="0" indent="0" algn="ctr">
               <a:buNone/>
             </a:pPr>
             <a:r>
@@ -6688,7 +6828,7 @@
           <a:bodyPr wrap="square" rtlCol="0" anchor="t"/>
           <a:lstStyle/>
           <a:p>
-            <a:pPr indent="0" marL="0">
+            <a:pPr marL="0" indent="0">
               <a:buNone/>
             </a:pPr>
             <a:r>
@@ -6730,6 +6870,13 @@
             <a:prstDash val="solid"/>
           </a:ln>
         </p:spPr>
+        <p:txBody>
+          <a:bodyPr/>
+          <a:lstStyle/>
+          <a:p>
+            <a:endParaRPr lang="en-US"/>
+          </a:p>
+        </p:txBody>
       </p:sp>
       <p:sp>
         <p:nvSpPr>
@@ -6752,7 +6899,7 @@
           <a:bodyPr wrap="square" rtlCol="0" anchor="ctr"/>
           <a:lstStyle/>
           <a:p>
-            <a:pPr algn="ctr" indent="0" marL="0">
+            <a:pPr marL="0" indent="0" algn="ctr">
               <a:buNone/>
             </a:pPr>
             <a:r>
@@ -6796,6 +6943,13 @@
             <a:prstDash val="solid"/>
           </a:ln>
         </p:spPr>
+        <p:txBody>
+          <a:bodyPr/>
+          <a:lstStyle/>
+          <a:p>
+            <a:endParaRPr lang="en-US"/>
+          </a:p>
+        </p:txBody>
       </p:sp>
       <p:sp>
         <p:nvSpPr>
@@ -6821,6 +6975,13 @@
             <a:prstDash val="solid"/>
           </a:ln>
         </p:spPr>
+        <p:txBody>
+          <a:bodyPr/>
+          <a:lstStyle/>
+          <a:p>
+            <a:endParaRPr lang="en-US"/>
+          </a:p>
+        </p:txBody>
       </p:sp>
       <p:sp>
         <p:nvSpPr>
@@ -6843,7 +7004,7 @@
           <a:bodyPr wrap="square" rtlCol="0" anchor="ctr"/>
           <a:lstStyle/>
           <a:p>
-            <a:pPr algn="ctr" indent="0" marL="0">
+            <a:pPr marL="0" indent="0" algn="ctr">
               <a:buNone/>
             </a:pPr>
             <a:r>
@@ -6882,7 +7043,7 @@
           <a:bodyPr wrap="square" rtlCol="0" anchor="ctr"/>
           <a:lstStyle/>
           <a:p>
-            <a:pPr algn="ctr" indent="0" marL="0">
+            <a:pPr marL="0" indent="0" algn="ctr">
               <a:buNone/>
             </a:pPr>
             <a:r>
@@ -6921,7 +7082,7 @@
           <a:bodyPr wrap="square" rtlCol="0" anchor="t"/>
           <a:lstStyle/>
           <a:p>
-            <a:pPr indent="0" marL="0">
+            <a:pPr marL="0" indent="0">
               <a:buNone/>
             </a:pPr>
             <a:r>
@@ -6963,6 +7124,13 @@
             <a:prstDash val="solid"/>
           </a:ln>
         </p:spPr>
+        <p:txBody>
+          <a:bodyPr/>
+          <a:lstStyle/>
+          <a:p>
+            <a:endParaRPr lang="en-US"/>
+          </a:p>
+        </p:txBody>
       </p:sp>
       <p:sp>
         <p:nvSpPr>
@@ -6985,7 +7153,7 @@
           <a:bodyPr wrap="square" rtlCol="0" anchor="ctr"/>
           <a:lstStyle/>
           <a:p>
-            <a:pPr algn="ctr" indent="0" marL="0">
+            <a:pPr marL="0" indent="0" algn="ctr">
               <a:buNone/>
             </a:pPr>
             <a:r>
@@ -7052,6 +7220,13 @@
             <a:prstDash val="solid"/>
           </a:ln>
         </p:spPr>
+        <p:txBody>
+          <a:bodyPr/>
+          <a:lstStyle/>
+          <a:p>
+            <a:endParaRPr lang="en-US"/>
+          </a:p>
+        </p:txBody>
       </p:sp>
       <p:sp>
         <p:nvSpPr>
@@ -7077,6 +7252,13 @@
             <a:prstDash val="solid"/>
           </a:ln>
         </p:spPr>
+        <p:txBody>
+          <a:bodyPr/>
+          <a:lstStyle/>
+          <a:p>
+            <a:endParaRPr lang="en-US"/>
+          </a:p>
+        </p:txBody>
       </p:sp>
       <p:sp>
         <p:nvSpPr>
@@ -7099,7 +7281,7 @@
           <a:bodyPr wrap="square" rtlCol="0" anchor="ctr"/>
           <a:lstStyle/>
           <a:p>
-            <a:pPr algn="l" indent="0" marL="0">
+            <a:pPr marL="0" indent="0" algn="l">
               <a:buNone/>
             </a:pPr>
             <a:r>
@@ -7119,21 +7301,21 @@
       </p:sp>
       <p:pic>
         <p:nvPicPr>
-          <p:cNvPr id="5" name="Image 0" descr="C:\Users\muham\OneDrive - UW-Madison\Spring_26\CS763_Somesh\project\FINAL\CS763-indirect_prompt_injection\figures\demo_tier2_mistral.gif">    </p:cNvPr>
+          <p:cNvPr id="5" name="Image 0" descr="C:\Users\muham\OneDrive - UW-Madison\Spring_26\CS763_Somesh\project\FINAL\CS763-indirect_prompt_injection\figures\demo_tier2_mistral.gif"/>
           <p:cNvPicPr>
             <a:picLocks noChangeAspect="1"/>
           </p:cNvPicPr>
           <p:nvPr/>
         </p:nvPicPr>
         <p:blipFill>
-          <a:blip r:embed="rId1"/>
+          <a:blip r:embed="rId3"/>
           <a:stretch>
             <a:fillRect/>
           </a:stretch>
         </p:blipFill>
         <p:spPr>
           <a:xfrm>
-            <a:off x="365760" y="960120"/>
+            <a:off x="365760" y="954258"/>
             <a:ext cx="11457432" cy="4572000"/>
           </a:xfrm>
           <a:prstGeom prst="rect">
@@ -7162,7 +7344,7 @@
           <a:bodyPr wrap="square" rtlCol="0" anchor="ctr"/>
           <a:lstStyle/>
           <a:p>
-            <a:pPr algn="ctr" indent="0" marL="0">
+            <a:pPr marL="0" indent="0" algn="ctr">
               <a:buNone/>
             </a:pPr>
             <a:r>
@@ -7229,6 +7411,13 @@
             <a:prstDash val="solid"/>
           </a:ln>
         </p:spPr>
+        <p:txBody>
+          <a:bodyPr/>
+          <a:lstStyle/>
+          <a:p>
+            <a:endParaRPr lang="en-US"/>
+          </a:p>
+        </p:txBody>
       </p:sp>
       <p:sp>
         <p:nvSpPr>
@@ -7254,6 +7443,13 @@
             <a:prstDash val="solid"/>
           </a:ln>
         </p:spPr>
+        <p:txBody>
+          <a:bodyPr/>
+          <a:lstStyle/>
+          <a:p>
+            <a:endParaRPr lang="en-US"/>
+          </a:p>
+        </p:txBody>
       </p:sp>
       <p:sp>
         <p:nvSpPr>
@@ -7276,7 +7472,7 @@
           <a:bodyPr wrap="square" rtlCol="0" anchor="ctr"/>
           <a:lstStyle/>
           <a:p>
-            <a:pPr algn="l" indent="0" marL="0">
+            <a:pPr marL="0" indent="0" algn="l">
               <a:buNone/>
             </a:pPr>
             <a:r>
@@ -7296,14 +7492,14 @@
       </p:sp>
       <p:pic>
         <p:nvPicPr>
-          <p:cNvPr id="5" name="Image 0" descr="C:\Users\muham\OneDrive - UW-Madison\Spring_26\CS763_Somesh\project\FINAL\CS763-indirect_prompt_injection\figures\diagram_b_defense_pipeline.png">    </p:cNvPr>
+          <p:cNvPr id="5" name="Image 0" descr="C:\Users\muham\OneDrive - UW-Madison\Spring_26\CS763_Somesh\project\FINAL\CS763-indirect_prompt_injection\figures\diagram_b_defense_pipeline.png"/>
           <p:cNvPicPr>
             <a:picLocks noChangeAspect="1"/>
           </p:cNvPicPr>
           <p:nvPr/>
         </p:nvPicPr>
         <p:blipFill>
-          <a:blip r:embed="rId1"/>
+          <a:blip r:embed="rId3"/>
           <a:stretch>
             <a:fillRect/>
           </a:stretch>
@@ -7515,6 +7711,13 @@
             <a:prstDash val="solid"/>
           </a:ln>
         </p:spPr>
+        <p:txBody>
+          <a:bodyPr/>
+          <a:lstStyle/>
+          <a:p>
+            <a:endParaRPr lang="en-US"/>
+          </a:p>
+        </p:txBody>
       </p:sp>
       <p:sp>
         <p:nvSpPr>
@@ -7540,6 +7743,13 @@
             <a:prstDash val="solid"/>
           </a:ln>
         </p:spPr>
+        <p:txBody>
+          <a:bodyPr/>
+          <a:lstStyle/>
+          <a:p>
+            <a:endParaRPr lang="en-US"/>
+          </a:p>
+        </p:txBody>
       </p:sp>
       <p:sp>
         <p:nvSpPr>
@@ -7562,7 +7772,7 @@
           <a:bodyPr wrap="square" rtlCol="0" anchor="ctr"/>
           <a:lstStyle/>
           <a:p>
-            <a:pPr algn="l" indent="0" marL="0">
+            <a:pPr marL="0" indent="0" algn="l">
               <a:buNone/>
             </a:pPr>
             <a:r>
@@ -7582,14 +7792,14 @@
       </p:sp>
       <p:pic>
         <p:nvPicPr>
-          <p:cNvPr id="5" name="Image 0" descr="C:\Users\muham\OneDrive - UW-Madison\Spring_26\CS763_Somesh\project\FINAL\CS763-indirect_prompt_injection\figures\fig1_arms_race.png">    </p:cNvPr>
+          <p:cNvPr id="5" name="Image 0" descr="C:\Users\muham\OneDrive - UW-Madison\Spring_26\CS763_Somesh\project\FINAL\CS763-indirect_prompt_injection\figures\fig1_arms_race.png"/>
           <p:cNvPicPr>
             <a:picLocks noChangeAspect="1"/>
           </p:cNvPicPr>
           <p:nvPr/>
         </p:nvPicPr>
         <p:blipFill>
-          <a:blip r:embed="rId1"/>
+          <a:blip r:embed="rId3"/>
           <a:stretch>
             <a:fillRect/>
           </a:stretch>
@@ -7625,7 +7835,7 @@
           <a:bodyPr wrap="square" rtlCol="0" anchor="ctr"/>
           <a:lstStyle/>
           <a:p>
-            <a:pPr algn="ctr" indent="0" marL="0">
+            <a:pPr marL="0" indent="0" algn="ctr">
               <a:buNone/>
             </a:pPr>
             <a:r>
@@ -7692,6 +7902,13 @@
             <a:prstDash val="solid"/>
           </a:ln>
         </p:spPr>
+        <p:txBody>
+          <a:bodyPr/>
+          <a:lstStyle/>
+          <a:p>
+            <a:endParaRPr lang="en-US"/>
+          </a:p>
+        </p:txBody>
       </p:sp>
       <p:sp>
         <p:nvSpPr>
@@ -7717,6 +7934,13 @@
             <a:prstDash val="solid"/>
           </a:ln>
         </p:spPr>
+        <p:txBody>
+          <a:bodyPr/>
+          <a:lstStyle/>
+          <a:p>
+            <a:endParaRPr lang="en-US"/>
+          </a:p>
+        </p:txBody>
       </p:sp>
       <p:sp>
         <p:nvSpPr>
@@ -7739,7 +7963,7 @@
           <a:bodyPr wrap="square" rtlCol="0" anchor="ctr"/>
           <a:lstStyle/>
           <a:p>
-            <a:pPr algn="l" indent="0" marL="0">
+            <a:pPr marL="0" indent="0" algn="l">
               <a:buNone/>
             </a:pPr>
             <a:r>
@@ -7783,6 +8007,13 @@
             <a:prstDash val="solid"/>
           </a:ln>
         </p:spPr>
+        <p:txBody>
+          <a:bodyPr/>
+          <a:lstStyle/>
+          <a:p>
+            <a:endParaRPr lang="en-US"/>
+          </a:p>
+        </p:txBody>
       </p:sp>
       <p:sp>
         <p:nvSpPr>
@@ -7805,7 +8036,7 @@
           <a:bodyPr wrap="square" rtlCol="0" anchor="ctr"/>
           <a:lstStyle/>
           <a:p>
-            <a:pPr indent="0" marL="0">
+            <a:pPr marL="0" indent="0">
               <a:buNone/>
             </a:pPr>
             <a:r>
@@ -7849,6 +8080,13 @@
             <a:prstDash val="solid"/>
           </a:ln>
         </p:spPr>
+        <p:txBody>
+          <a:bodyPr/>
+          <a:lstStyle/>
+          <a:p>
+            <a:endParaRPr lang="en-US"/>
+          </a:p>
+        </p:txBody>
       </p:sp>
       <p:sp>
         <p:nvSpPr>
@@ -7871,7 +8109,7 @@
           <a:bodyPr wrap="square" rtlCol="0" anchor="ctr"/>
           <a:lstStyle/>
           <a:p>
-            <a:pPr algn="ctr" indent="0" marL="0">
+            <a:pPr marL="0" indent="0" algn="ctr">
               <a:buNone/>
             </a:pPr>
             <a:r>
@@ -7888,7 +8126,7 @@
             <a:endParaRPr lang="en-US" sz="2200" dirty="0"/>
           </a:p>
           <a:p>
-            <a:pPr algn="ctr" indent="0" marL="0">
+            <a:pPr marL="0" indent="0" algn="ctr">
               <a:buNone/>
             </a:pPr>
             <a:r>
@@ -7932,6 +8170,13 @@
             <a:prstDash val="solid"/>
           </a:ln>
         </p:spPr>
+        <p:txBody>
+          <a:bodyPr/>
+          <a:lstStyle/>
+          <a:p>
+            <a:endParaRPr lang="en-US"/>
+          </a:p>
+        </p:txBody>
       </p:sp>
       <p:sp>
         <p:nvSpPr>
@@ -7954,7 +8199,7 @@
           <a:bodyPr wrap="square" rtlCol="0" anchor="ctr"/>
           <a:lstStyle/>
           <a:p>
-            <a:pPr algn="ctr" indent="0" marL="0">
+            <a:pPr marL="0" indent="0" algn="ctr">
               <a:buNone/>
             </a:pPr>
             <a:r>
@@ -7971,7 +8216,7 @@
             <a:endParaRPr lang="en-US" sz="2200" dirty="0"/>
           </a:p>
           <a:p>
-            <a:pPr algn="ctr" indent="0" marL="0">
+            <a:pPr marL="0" indent="0" algn="ctr">
               <a:buNone/>
             </a:pPr>
             <a:r>
@@ -8013,6 +8258,13 @@
             <a:prstDash val="solid"/>
           </a:ln>
         </p:spPr>
+        <p:txBody>
+          <a:bodyPr/>
+          <a:lstStyle/>
+          <a:p>
+            <a:endParaRPr lang="en-US"/>
+          </a:p>
+        </p:txBody>
       </p:sp>
       <p:sp>
         <p:nvSpPr>
@@ -8400,4 +8652,319 @@
     </a:ext>
   </a:extLst>
 </a:theme>
+</file>
+
+<file path=ppt/theme/theme2.xml><?xml version="1.0" encoding="utf-8"?>
+<a:theme xmlns:a="http://schemas.openxmlformats.org/drawingml/2006/main" name="Office Theme">
+  <a:themeElements>
+    <a:clrScheme name="Office">
+      <a:dk1>
+        <a:sysClr val="windowText" lastClr="000000"/>
+      </a:dk1>
+      <a:lt1>
+        <a:sysClr val="window" lastClr="FFFFFF"/>
+      </a:lt1>
+      <a:dk2>
+        <a:srgbClr val="0E2841"/>
+      </a:dk2>
+      <a:lt2>
+        <a:srgbClr val="E8E8E8"/>
+      </a:lt2>
+      <a:accent1>
+        <a:srgbClr val="156082"/>
+      </a:accent1>
+      <a:accent2>
+        <a:srgbClr val="E97132"/>
+      </a:accent2>
+      <a:accent3>
+        <a:srgbClr val="196B24"/>
+      </a:accent3>
+      <a:accent4>
+        <a:srgbClr val="0F9ED5"/>
+      </a:accent4>
+      <a:accent5>
+        <a:srgbClr val="A02B93"/>
+      </a:accent5>
+      <a:accent6>
+        <a:srgbClr val="4EA72E"/>
+      </a:accent6>
+      <a:hlink>
+        <a:srgbClr val="467886"/>
+      </a:hlink>
+      <a:folHlink>
+        <a:srgbClr val="96607D"/>
+      </a:folHlink>
+    </a:clrScheme>
+    <a:fontScheme name="Office">
+      <a:majorFont>
+        <a:latin typeface="Aptos Display" panose="02110004020202020204"/>
+        <a:ea typeface=""/>
+        <a:cs typeface=""/>
+        <a:font script="Jpan" typeface="游ゴシック Light"/>
+        <a:font script="Hang" typeface="맑은 고딕"/>
+        <a:font script="Hans" typeface="等线 Light"/>
+        <a:font script="Hant" typeface="新細明體"/>
+        <a:font script="Arab" typeface="Times New Roman"/>
+        <a:font script="Hebr" typeface="Times New Roman"/>
+        <a:font script="Thai" typeface="Angsana New"/>
+        <a:font script="Ethi" typeface="Nyala"/>
+        <a:font script="Beng" typeface="Vrinda"/>
+        <a:font script="Gujr" typeface="Shruti"/>
+        <a:font script="Khmr" typeface="MoolBoran"/>
+        <a:font script="Knda" typeface="Tunga"/>
+        <a:font script="Guru" typeface="Raavi"/>
+        <a:font script="Cans" typeface="Euphemia"/>
+        <a:font script="Cher" typeface="Plantagenet Cherokee"/>
+        <a:font script="Yiii" typeface="Microsoft Yi Baiti"/>
+        <a:font script="Tibt" typeface="Microsoft Himalaya"/>
+        <a:font script="Thaa" typeface="MV Boli"/>
+        <a:font script="Deva" typeface="Mangal"/>
+        <a:font script="Telu" typeface="Gautami"/>
+        <a:font script="Taml" typeface="Latha"/>
+        <a:font script="Syrc" typeface="Estrangelo Edessa"/>
+        <a:font script="Orya" typeface="Kalinga"/>
+        <a:font script="Mlym" typeface="Kartika"/>
+        <a:font script="Laoo" typeface="DokChampa"/>
+        <a:font script="Sinh" typeface="Iskoola Pota"/>
+        <a:font script="Mong" typeface="Mongolian Baiti"/>
+        <a:font script="Viet" typeface="Times New Roman"/>
+        <a:font script="Uigh" typeface="Microsoft Uighur"/>
+        <a:font script="Geor" typeface="Sylfaen"/>
+        <a:font script="Armn" typeface="Arial"/>
+        <a:font script="Bugi" typeface="Leelawadee UI"/>
+        <a:font script="Bopo" typeface="Microsoft JhengHei"/>
+        <a:font script="Java" typeface="Javanese Text"/>
+        <a:font script="Lisu" typeface="Segoe UI"/>
+        <a:font script="Mymr" typeface="Myanmar Text"/>
+        <a:font script="Nkoo" typeface="Ebrima"/>
+        <a:font script="Olck" typeface="Nirmala UI"/>
+        <a:font script="Osma" typeface="Ebrima"/>
+        <a:font script="Phag" typeface="Phagspa"/>
+        <a:font script="Syrn" typeface="Estrangelo Edessa"/>
+        <a:font script="Syrj" typeface="Estrangelo Edessa"/>
+        <a:font script="Syre" typeface="Estrangelo Edessa"/>
+        <a:font script="Sora" typeface="Nirmala UI"/>
+        <a:font script="Tale" typeface="Microsoft Tai Le"/>
+        <a:font script="Talu" typeface="Microsoft New Tai Lue"/>
+        <a:font script="Tfng" typeface="Ebrima"/>
+      </a:majorFont>
+      <a:minorFont>
+        <a:latin typeface="Aptos" panose="02110004020202020204"/>
+        <a:ea typeface=""/>
+        <a:cs typeface=""/>
+        <a:font script="Jpan" typeface="游ゴシック"/>
+        <a:font script="Hang" typeface="맑은 고딕"/>
+        <a:font script="Hans" typeface="等线"/>
+        <a:font script="Hant" typeface="新細明體"/>
+        <a:font script="Arab" typeface="Arial"/>
+        <a:font script="Hebr" typeface="Arial"/>
+        <a:font script="Thai" typeface="Cordia New"/>
+        <a:font script="Ethi" typeface="Nyala"/>
+        <a:font script="Beng" typeface="Vrinda"/>
+        <a:font script="Gujr" typeface="Shruti"/>
+        <a:font script="Khmr" typeface="DaunPenh"/>
+        <a:font script="Knda" typeface="Tunga"/>
+        <a:font script="Guru" typeface="Raavi"/>
+        <a:font script="Cans" typeface="Euphemia"/>
+        <a:font script="Cher" typeface="Plantagenet Cherokee"/>
+        <a:font script="Yiii" typeface="Microsoft Yi Baiti"/>
+        <a:font script="Tibt" typeface="Microsoft Himalaya"/>
+        <a:font script="Thaa" typeface="MV Boli"/>
+        <a:font script="Deva" typeface="Mangal"/>
+        <a:font script="Telu" typeface="Gautami"/>
+        <a:font script="Taml" typeface="Latha"/>
+        <a:font script="Syrc" typeface="Estrangelo Edessa"/>
+        <a:font script="Orya" typeface="Kalinga"/>
+        <a:font script="Mlym" typeface="Kartika"/>
+        <a:font script="Laoo" typeface="DokChampa"/>
+        <a:font script="Sinh" typeface="Iskoola Pota"/>
+        <a:font script="Mong" typeface="Mongolian Baiti"/>
+        <a:font script="Viet" typeface="Arial"/>
+        <a:font script="Uigh" typeface="Microsoft Uighur"/>
+        <a:font script="Geor" typeface="Sylfaen"/>
+        <a:font script="Armn" typeface="Arial"/>
+        <a:font script="Bugi" typeface="Leelawadee UI"/>
+        <a:font script="Bopo" typeface="Microsoft JhengHei"/>
+        <a:font script="Java" typeface="Javanese Text"/>
+        <a:font script="Lisu" typeface="Segoe UI"/>
+        <a:font script="Mymr" typeface="Myanmar Text"/>
+        <a:font script="Nkoo" typeface="Ebrima"/>
+        <a:font script="Olck" typeface="Nirmala UI"/>
+        <a:font script="Osma" typeface="Ebrima"/>
+        <a:font script="Phag" typeface="Phagspa"/>
+        <a:font script="Syrn" typeface="Estrangelo Edessa"/>
+        <a:font script="Syrj" typeface="Estrangelo Edessa"/>
+        <a:font script="Syre" typeface="Estrangelo Edessa"/>
+        <a:font script="Sora" typeface="Nirmala UI"/>
+        <a:font script="Tale" typeface="Microsoft Tai Le"/>
+        <a:font script="Talu" typeface="Microsoft New Tai Lue"/>
+        <a:font script="Tfng" typeface="Ebrima"/>
+      </a:minorFont>
+    </a:fontScheme>
+    <a:fmtScheme name="Office">
+      <a:fillStyleLst>
+        <a:solidFill>
+          <a:schemeClr val="phClr"/>
+        </a:solidFill>
+        <a:gradFill rotWithShape="1">
+          <a:gsLst>
+            <a:gs pos="0">
+              <a:schemeClr val="phClr">
+                <a:lumMod val="110000"/>
+                <a:satMod val="105000"/>
+                <a:tint val="67000"/>
+              </a:schemeClr>
+            </a:gs>
+            <a:gs pos="50000">
+              <a:schemeClr val="phClr">
+                <a:lumMod val="105000"/>
+                <a:satMod val="103000"/>
+                <a:tint val="73000"/>
+              </a:schemeClr>
+            </a:gs>
+            <a:gs pos="100000">
+              <a:schemeClr val="phClr">
+                <a:lumMod val="105000"/>
+                <a:satMod val="109000"/>
+                <a:tint val="81000"/>
+              </a:schemeClr>
+            </a:gs>
+          </a:gsLst>
+          <a:lin ang="5400000" scaled="0"/>
+        </a:gradFill>
+        <a:gradFill rotWithShape="1">
+          <a:gsLst>
+            <a:gs pos="0">
+              <a:schemeClr val="phClr">
+                <a:satMod val="103000"/>
+                <a:lumMod val="102000"/>
+                <a:tint val="94000"/>
+              </a:schemeClr>
+            </a:gs>
+            <a:gs pos="50000">
+              <a:schemeClr val="phClr">
+                <a:satMod val="110000"/>
+                <a:lumMod val="100000"/>
+                <a:shade val="100000"/>
+              </a:schemeClr>
+            </a:gs>
+            <a:gs pos="100000">
+              <a:schemeClr val="phClr">
+                <a:lumMod val="99000"/>
+                <a:satMod val="120000"/>
+                <a:shade val="78000"/>
+              </a:schemeClr>
+            </a:gs>
+          </a:gsLst>
+          <a:lin ang="5400000" scaled="0"/>
+        </a:gradFill>
+      </a:fillStyleLst>
+      <a:lnStyleLst>
+        <a:ln w="12700" cap="flat" cmpd="sng" algn="ctr">
+          <a:solidFill>
+            <a:schemeClr val="phClr"/>
+          </a:solidFill>
+          <a:prstDash val="solid"/>
+          <a:miter lim="800000"/>
+        </a:ln>
+        <a:ln w="19050" cap="flat" cmpd="sng" algn="ctr">
+          <a:solidFill>
+            <a:schemeClr val="phClr"/>
+          </a:solidFill>
+          <a:prstDash val="solid"/>
+          <a:miter lim="800000"/>
+        </a:ln>
+        <a:ln w="25400" cap="flat" cmpd="sng" algn="ctr">
+          <a:solidFill>
+            <a:schemeClr val="phClr"/>
+          </a:solidFill>
+          <a:prstDash val="solid"/>
+          <a:miter lim="800000"/>
+        </a:ln>
+      </a:lnStyleLst>
+      <a:effectStyleLst>
+        <a:effectStyle>
+          <a:effectLst/>
+        </a:effectStyle>
+        <a:effectStyle>
+          <a:effectLst/>
+        </a:effectStyle>
+        <a:effectStyle>
+          <a:effectLst>
+            <a:outerShdw blurRad="57150" dist="19050" dir="5400000" algn="ctr" rotWithShape="0">
+              <a:srgbClr val="000000">
+                <a:alpha val="63000"/>
+              </a:srgbClr>
+            </a:outerShdw>
+          </a:effectLst>
+        </a:effectStyle>
+      </a:effectStyleLst>
+      <a:bgFillStyleLst>
+        <a:solidFill>
+          <a:schemeClr val="phClr"/>
+        </a:solidFill>
+        <a:solidFill>
+          <a:schemeClr val="phClr">
+            <a:tint val="95000"/>
+            <a:satMod val="170000"/>
+          </a:schemeClr>
+        </a:solidFill>
+        <a:gradFill rotWithShape="1">
+          <a:gsLst>
+            <a:gs pos="0">
+              <a:schemeClr val="phClr">
+                <a:tint val="93000"/>
+                <a:satMod val="150000"/>
+                <a:shade val="98000"/>
+                <a:lumMod val="102000"/>
+              </a:schemeClr>
+            </a:gs>
+            <a:gs pos="50000">
+              <a:schemeClr val="phClr">
+                <a:tint val="98000"/>
+                <a:satMod val="130000"/>
+                <a:shade val="90000"/>
+                <a:lumMod val="103000"/>
+              </a:schemeClr>
+            </a:gs>
+            <a:gs pos="100000">
+              <a:schemeClr val="phClr">
+                <a:shade val="63000"/>
+                <a:satMod val="120000"/>
+              </a:schemeClr>
+            </a:gs>
+          </a:gsLst>
+          <a:lin ang="5400000" scaled="0"/>
+        </a:gradFill>
+      </a:bgFillStyleLst>
+    </a:fmtScheme>
+  </a:themeElements>
+  <a:objectDefaults>
+    <a:lnDef>
+      <a:spPr/>
+      <a:bodyPr/>
+      <a:lstStyle/>
+      <a:style>
+        <a:lnRef idx="2">
+          <a:schemeClr val="accent1"/>
+        </a:lnRef>
+        <a:fillRef idx="0">
+          <a:schemeClr val="accent1"/>
+        </a:fillRef>
+        <a:effectRef idx="1">
+          <a:schemeClr val="accent1"/>
+        </a:effectRef>
+        <a:fontRef idx="minor">
+          <a:schemeClr val="tx1"/>
+        </a:fontRef>
+      </a:style>
+    </a:lnDef>
+  </a:objectDefaults>
+  <a:extraClrSchemeLst/>
+  <a:extLst>
+    <a:ext uri="{05A4C25C-085E-4340-85A3-A5531E510DB2}">
+      <thm15:themeFamily xmlns:thm15="http://schemas.microsoft.com/office/thememl/2012/main" name="Office Theme" id="{2E142A2C-CD16-42D6-873A-C26D2A0506FA}" vid="{1BDDFF52-6CD6-40A5-AB3C-68EB2F1E4D0A}"/>
+    </a:ext>
+  </a:extLst>
+</a:theme>
 </file>
</xml_diff>